<commit_message>
Brand the login and decks: adani wordmark + Powered by Mobilise
Adani wordmark drawn as round-capped vector strokes with the brand
gradient (#0B74B0 -> #75479C -> #BD3861) — no font dependency; white
variant on the login panorama, gradient variant on the sign-in panel.
'Powered by Mobilise · mobilise.co.in' lockup with an M badge on the
login and on both decks' title/closing slides (transparent PNGs rendered
from the same SVGs in build/assets/). Both sites are blocked by this
environment's egress policy, so the marks are faithful recreations kept
as single swappable assets.

Co-Authored-By: Claude <noreply@anthropic.com>
Claude-Session: https://claude.ai/code/session_0144pWb7gaUkrE87cb3A7msY
</commit_message>
<xml_diff>
--- a/dist/mundra-portal-project-presentation.pptx
+++ b/dist/mundra-portal-project-presentation.pptx
@@ -3832,9 +3832,33 @@
           <a:ln/>
         </p:spPr>
       </p:sp>
-      <p:sp>
-        <p:nvSpPr>
-          <p:cNvPr id="3" name="Text 1"/>
+      <p:pic>
+        <p:nvPicPr>
+          <p:cNvPr id="3" name="Image 0" descr="/home/user/maritime-project-presentation/build/assets/adani-white.png">    </p:cNvPr>
+          <p:cNvPicPr>
+            <a:picLocks noChangeAspect="1"/>
+          </p:cNvPicPr>
+          <p:nvPr/>
+        </p:nvPicPr>
+        <p:blipFill>
+          <a:blip r:embed="rId1"/>
+          <a:stretch>
+            <a:fillRect/>
+          </a:stretch>
+        </p:blipFill>
+        <p:spPr>
+          <a:xfrm>
+            <a:off x="9814255" y="548640"/>
+            <a:ext cx="1728216" cy="548640"/>
+          </a:xfrm>
+          <a:prstGeom prst="rect">
+            <a:avLst/>
+          </a:prstGeom>
+        </p:spPr>
+      </p:pic>
+      <p:sp>
+        <p:nvSpPr>
+          <p:cNvPr id="4" name="Text 1"/>
           <p:cNvSpPr/>
           <p:nvPr/>
         </p:nvSpPr>
@@ -3865,7 +3889,7 @@
                 <a:ea typeface="Calibri" pitchFamily="34" charset="-122"/>
                 <a:cs typeface="Calibri" pitchFamily="34" charset="-120"/>
               </a:rPr>
-              <a:t>MOBILISE APP LAB · PROJECT PRESENTATION</a:t>
+              <a:t>PROJECT PRESENTATION</a:t>
             </a:r>
             <a:endParaRPr lang="en-US" sz="1300" dirty="0"/>
           </a:p>
@@ -3873,7 +3897,7 @@
       </p:sp>
       <p:sp>
         <p:nvSpPr>
-          <p:cNvPr id="4" name="Text 2"/>
+          <p:cNvPr id="5" name="Text 2"/>
           <p:cNvSpPr/>
           <p:nvPr/>
         </p:nvSpPr>
@@ -3935,7 +3959,7 @@
       </p:sp>
       <p:sp>
         <p:nvSpPr>
-          <p:cNvPr id="5" name="Text 3"/>
+          <p:cNvPr id="6" name="Text 3"/>
           <p:cNvSpPr/>
           <p:nvPr/>
         </p:nvSpPr>
@@ -3974,7 +3998,7 @@
       </p:sp>
       <p:sp>
         <p:nvSpPr>
-          <p:cNvPr id="6" name="Text 4"/>
+          <p:cNvPr id="7" name="Text 4"/>
           <p:cNvSpPr/>
           <p:nvPr/>
         </p:nvSpPr>
@@ -4008,6 +4032,98 @@
               <a:t>August 2026</a:t>
             </a:r>
             <a:endParaRPr lang="en-US" sz="1300" dirty="0"/>
+          </a:p>
+        </p:txBody>
+      </p:sp>
+      <p:pic>
+        <p:nvPicPr>
+          <p:cNvPr id="8" name="Image 1" descr="/home/user/maritime-project-presentation/build/assets/mobilise-badge-white.png">    </p:cNvPr>
+          <p:cNvPicPr>
+            <a:picLocks noChangeAspect="1"/>
+          </p:cNvPicPr>
+          <p:nvPr/>
+        </p:nvPicPr>
+        <p:blipFill>
+          <a:blip r:embed="rId2"/>
+          <a:stretch>
+            <a:fillRect/>
+          </a:stretch>
+        </p:blipFill>
+        <p:spPr>
+          <a:xfrm>
+            <a:off x="868680" y="5806440"/>
+            <a:ext cx="384048" cy="384048"/>
+          </a:xfrm>
+          <a:prstGeom prst="rect">
+            <a:avLst/>
+          </a:prstGeom>
+        </p:spPr>
+      </p:pic>
+      <p:sp>
+        <p:nvSpPr>
+          <p:cNvPr id="9" name="Text 5"/>
+          <p:cNvSpPr/>
+          <p:nvPr/>
+        </p:nvSpPr>
+        <p:spPr>
+          <a:xfrm>
+            <a:off x="1371600" y="5760720"/>
+            <a:ext cx="5486400" cy="502920"/>
+          </a:xfrm>
+          <a:prstGeom prst="rect">
+            <a:avLst/>
+          </a:prstGeom>
+          <a:noFill/>
+          <a:ln/>
+        </p:spPr>
+        <p:txBody>
+          <a:bodyPr wrap="square" lIns="0" tIns="0" rIns="0" bIns="0" rtlCol="0" anchor="ctr"/>
+          <a:lstStyle/>
+          <a:p>
+            <a:pPr indent="0" marL="0">
+              <a:buNone/>
+            </a:pPr>
+            <a:r>
+              <a:rPr lang="en-US" sz="850" spc="200" kern="0" dirty="0">
+                <a:solidFill>
+                  <a:srgbClr val="7A93A0"/>
+                </a:solidFill>
+                <a:latin typeface="Calibri" pitchFamily="34" charset="0"/>
+                <a:ea typeface="Calibri" pitchFamily="34" charset="-122"/>
+                <a:cs typeface="Calibri" pitchFamily="34" charset="-120"/>
+              </a:rPr>
+              <a:t>POWERED BY
+</a:t>
+            </a:r>
+            <a:pPr indent="0" marL="0">
+              <a:buNone/>
+            </a:pPr>
+            <a:r>
+              <a:rPr lang="en-US" sz="1300" b="1" dirty="0">
+                <a:solidFill>
+                  <a:srgbClr val="FFFFFF"/>
+                </a:solidFill>
+                <a:latin typeface="Calibri" pitchFamily="34" charset="0"/>
+                <a:ea typeface="Calibri" pitchFamily="34" charset="-122"/>
+                <a:cs typeface="Calibri" pitchFamily="34" charset="-120"/>
+              </a:rPr>
+              <a:t>Mobilise App Lab</a:t>
+            </a:r>
+            <a:pPr indent="0" marL="0">
+              <a:buNone/>
+            </a:pPr>
+            <a:r>
+              <a:rPr lang="en-US" sz="1000" dirty="0">
+                <a:solidFill>
+                  <a:srgbClr val="7FC7CC"/>
+                </a:solidFill>
+                <a:latin typeface="Calibri" pitchFamily="34" charset="0"/>
+                <a:ea typeface="Calibri" pitchFamily="34" charset="-122"/>
+                <a:cs typeface="Calibri" pitchFamily="34" charset="-120"/>
+              </a:rPr>
+              <a:t>  ·  mobilise.co.in</a:t>
+            </a:r>
+            <a:endParaRPr lang="en-US" sz="850" dirty="0"/>
           </a:p>
         </p:txBody>
       </p:sp>
@@ -23415,9 +23531,33 @@
           <a:chExt cx="0" cy="0"/>
         </a:xfrm>
       </p:grpSpPr>
-      <p:sp>
-        <p:nvSpPr>
-          <p:cNvPr id="2" name="Text 0"/>
+      <p:pic>
+        <p:nvPicPr>
+          <p:cNvPr id="2" name="Image 0" descr="/home/user/maritime-project-presentation/build/assets/adani-white.png">    </p:cNvPr>
+          <p:cNvPicPr>
+            <a:picLocks noChangeAspect="1"/>
+          </p:cNvPicPr>
+          <p:nvPr/>
+        </p:nvPicPr>
+        <p:blipFill>
+          <a:blip r:embed="rId1"/>
+          <a:stretch>
+            <a:fillRect/>
+          </a:stretch>
+        </p:blipFill>
+        <p:spPr>
+          <a:xfrm>
+            <a:off x="9814255" y="548640"/>
+            <a:ext cx="1728216" cy="548640"/>
+          </a:xfrm>
+          <a:prstGeom prst="rect">
+            <a:avLst/>
+          </a:prstGeom>
+        </p:spPr>
+      </p:pic>
+      <p:sp>
+        <p:nvSpPr>
+          <p:cNvPr id="3" name="Text 0"/>
           <p:cNvSpPr/>
           <p:nvPr/>
         </p:nvSpPr>
@@ -23456,7 +23596,7 @@
       </p:sp>
       <p:sp>
         <p:nvSpPr>
-          <p:cNvPr id="3" name="Text 1"/>
+          <p:cNvPr id="4" name="Text 1"/>
           <p:cNvSpPr/>
           <p:nvPr/>
         </p:nvSpPr>
@@ -23495,7 +23635,7 @@
       </p:sp>
       <p:sp>
         <p:nvSpPr>
-          <p:cNvPr id="4" name="Shape 2"/>
+          <p:cNvPr id="5" name="Shape 2"/>
           <p:cNvSpPr/>
           <p:nvPr/>
         </p:nvSpPr>
@@ -23513,16 +23653,40 @@
           <a:ln/>
         </p:spPr>
       </p:sp>
-      <p:sp>
-        <p:nvSpPr>
-          <p:cNvPr id="5" name="Text 3"/>
-          <p:cNvSpPr/>
-          <p:nvPr/>
-        </p:nvSpPr>
-        <p:spPr>
-          <a:xfrm>
-            <a:off x="868680" y="4389120"/>
-            <a:ext cx="7315200" cy="411480"/>
+      <p:pic>
+        <p:nvPicPr>
+          <p:cNvPr id="6" name="Image 1" descr="/home/user/maritime-project-presentation/build/assets/mobilise-badge-white.png">    </p:cNvPr>
+          <p:cNvPicPr>
+            <a:picLocks noChangeAspect="1"/>
+          </p:cNvPicPr>
+          <p:nvPr/>
+        </p:nvPicPr>
+        <p:blipFill>
+          <a:blip r:embed="rId2"/>
+          <a:stretch>
+            <a:fillRect/>
+          </a:stretch>
+        </p:blipFill>
+        <p:spPr>
+          <a:xfrm>
+            <a:off x="868680" y="4434840"/>
+            <a:ext cx="384048" cy="384048"/>
+          </a:xfrm>
+          <a:prstGeom prst="rect">
+            <a:avLst/>
+          </a:prstGeom>
+        </p:spPr>
+      </p:pic>
+      <p:sp>
+        <p:nvSpPr>
+          <p:cNvPr id="7" name="Text 3"/>
+          <p:cNvSpPr/>
+          <p:nvPr/>
+        </p:nvSpPr>
+        <p:spPr>
+          <a:xfrm>
+            <a:off x="1371600" y="4389120"/>
+            <a:ext cx="5486400" cy="502920"/>
           </a:xfrm>
           <a:prstGeom prst="rect">
             <a:avLst/>
@@ -23538,7 +23702,22 @@
               <a:buNone/>
             </a:pPr>
             <a:r>
-              <a:rPr lang="en-US" sz="1500" b="1" dirty="0">
+              <a:rPr lang="en-US" sz="850" spc="200" kern="0" dirty="0">
+                <a:solidFill>
+                  <a:srgbClr val="7A93A0"/>
+                </a:solidFill>
+                <a:latin typeface="Calibri" pitchFamily="34" charset="0"/>
+                <a:ea typeface="Calibri" pitchFamily="34" charset="-122"/>
+                <a:cs typeface="Calibri" pitchFamily="34" charset="-120"/>
+              </a:rPr>
+              <a:t>POWERED BY
+</a:t>
+            </a:r>
+            <a:pPr indent="0" marL="0">
+              <a:buNone/>
+            </a:pPr>
+            <a:r>
+              <a:rPr lang="en-US" sz="1300" b="1" dirty="0">
                 <a:solidFill>
                   <a:srgbClr val="FFFFFF"/>
                 </a:solidFill>
@@ -23548,7 +23727,21 @@
               </a:rPr>
               <a:t>Mobilise App Lab</a:t>
             </a:r>
-            <a:endParaRPr lang="en-US" sz="1500" dirty="0"/>
+            <a:pPr indent="0" marL="0">
+              <a:buNone/>
+            </a:pPr>
+            <a:r>
+              <a:rPr lang="en-US" sz="1000" dirty="0">
+                <a:solidFill>
+                  <a:srgbClr val="7FC7CC"/>
+                </a:solidFill>
+                <a:latin typeface="Calibri" pitchFamily="34" charset="0"/>
+                <a:ea typeface="Calibri" pitchFamily="34" charset="-122"/>
+                <a:cs typeface="Calibri" pitchFamily="34" charset="-120"/>
+              </a:rPr>
+              <a:t>  ·  mobilise.co.in</a:t>
+            </a:r>
+            <a:endParaRPr lang="en-US" sz="850" dirty="0"/>
           </a:p>
         </p:txBody>
       </p:sp>

</xml_diff>